<commit_message>
refactor: update documentation and improve setup instructions
- Removed outdated Documentation.zip file.
- Enhanced clarity and detail in the build_presentation.py and build_setup_doc.py scripts, including updated bullet points and section headings for better readability.
- Updated chain_data.json with the latest blockchain state, reflecting changes in lastUpdated and currentBlock values.
- Made various adjustments across multiple documentation files to ensure consistency and accuracy.
</commit_message>
<xml_diff>
--- a/Documentation/presentation.pptx
+++ b/Documentation/presentation.pptx
@@ -4269,7 +4269,7 @@
                 </a:solidFill>
                 <a:latin typeface="Calibri"/>
               </a:rPr>
-              <a:t>8. Limitations &amp; Future Work</a:t>
+              <a:t>8. Constraints &amp; Future Scope</a:t>
             </a:r>
           </a:p>
         </p:txBody>
@@ -4417,7 +4417,7 @@
                 </a:solidFill>
                 <a:latin typeface="Calibri"/>
               </a:rPr>
-              <a:t>Current Limitations</a:t>
+              <a:t>System Boundaries</a:t>
             </a:r>
           </a:p>
         </p:txBody>
@@ -4499,7 +4499,7 @@
                 </a:solidFill>
                 <a:latin typeface="Calibri"/>
               </a:rPr>
-              <a:t>  • BB84 is a software simulation — no real quantum hardware used</a:t>
+              <a:t>  • BB84 execution relies on software matrix simulation rather than physical photonic hardware</a:t>
             </a:r>
           </a:p>
           <a:p>
@@ -4515,7 +4515,7 @@
                 </a:solidFill>
                 <a:latin typeface="Calibri"/>
               </a:rPr>
-              <a:t>  • Hyperledger Besu runs on a single-node local instance, not a production multi-node consortium</a:t>
+              <a:t>  • Hyperledger Besu operates as a single-node local container rather than a distributed consortium network</a:t>
             </a:r>
           </a:p>
           <a:p>
@@ -4531,7 +4531,7 @@
                 </a:solidFill>
                 <a:latin typeface="Calibri"/>
               </a:rPr>
-              <a:t>  • No integration with external SSO / LMS platforms (e.g., Moodle, Banner, SAML)</a:t>
+              <a:t>  • No integration with institutional identity providers (e.g. Moodle, Shibboleth, SAML)</a:t>
             </a:r>
           </a:p>
           <a:p>
@@ -4547,7 +4547,7 @@
                 </a:solidFill>
                 <a:latin typeface="Calibri"/>
               </a:rPr>
-              <a:t>  • Mobile devices are not supported — web browser on desktop only</a:t>
+              <a:t>  • Application interface optimized for desktop browsers; mobile screen support is limited</a:t>
             </a:r>
           </a:p>
           <a:p>
@@ -4563,7 +4563,7 @@
                 </a:solidFill>
                 <a:latin typeface="Calibri"/>
               </a:rPr>
-              <a:t>  • Real-time video and voice calling are out of scope</a:t>
+              <a:t>  • Real-time audio and video conferencing are omitted from current project scope</a:t>
             </a:r>
           </a:p>
         </p:txBody>
@@ -4723,7 +4723,7 @@
                 </a:solidFill>
                 <a:latin typeface="Calibri"/>
               </a:rPr>
-              <a:t>  • Deploy a multi-node Besu consortium across UENR departments for production-grade immutability</a:t>
+              <a:t>  • Deploy a multi-node Besu consortium network across university department servers</a:t>
             </a:r>
           </a:p>
           <a:p>
@@ -4739,7 +4739,7 @@
                 </a:solidFill>
                 <a:latin typeface="Calibri"/>
               </a:rPr>
-              <a:t>  • Integrate real QKD cloud APIs (e.g., Toshiba Quantum, ID Quantique) to replace simulation</a:t>
+              <a:t>  • Connect to commercial QKD cloud APIs (e.g., Toshiba QKD) for hardware key generation</a:t>
             </a:r>
           </a:p>
           <a:p>
@@ -4755,7 +4755,7 @@
                 </a:solidFill>
                 <a:latin typeface="Calibri"/>
               </a:rPr>
-              <a:t>  • Add OAuth2 / SAML 2.0 SSO for institutional federated identity (LMS integration)</a:t>
+              <a:t>  • Implement SAML 2.0 / OAuth2 single sign-on integration for university identity management</a:t>
             </a:r>
           </a:p>
           <a:p>
@@ -4771,7 +4771,7 @@
                 </a:solidFill>
                 <a:latin typeface="Calibri"/>
               </a:rPr>
-              <a:t>  • Build React Native mobile apps for iOS and Android</a:t>
+              <a:t>  • Develop React Native mobile applications targeting Android and iOS devices</a:t>
             </a:r>
           </a:p>
           <a:p>
@@ -4787,7 +4787,7 @@
                 </a:solidFill>
                 <a:latin typeface="Calibri"/>
               </a:rPr>
-              <a:t>  • Conduct 1,000+ concurrent user load testing to establish Convex scalability metrics</a:t>
+              <a:t>  • Perform large-scale concurrent stress testing to establish Convex cloud load boundaries</a:t>
             </a:r>
           </a:p>
         </p:txBody>
@@ -5055,7 +5055,7 @@
                 </a:solidFill>
                 <a:latin typeface="Calibri"/>
               </a:rPr>
-              <a:t>9. Conclusion</a:t>
+              <a:t>9. Summary &amp; Conclusion</a:t>
             </a:r>
           </a:p>
         </p:txBody>
@@ -5207,7 +5207,7 @@
                 </a:solidFill>
                 <a:latin typeface="Calibri"/>
               </a:rPr>
-              <a:t>  • All 6 project objectives were successfully achieved within the defined project scope</a:t>
+              <a:t>  • Successfully achieved all 6 project objectives within the established research framework</a:t>
             </a:r>
           </a:p>
           <a:p>
@@ -5223,7 +5223,7 @@
                 </a:solidFill>
                 <a:latin typeface="Calibri"/>
               </a:rPr>
-              <a:t>  • QChat demonstrates that a hybrid Web2/Web3 architecture delivers both real-time performance AND cryptographic auditability</a:t>
+              <a:t>  • Proved that combining Web2 real-time sockets with Web3 blockchain storage resolves the performance vs. verification dilemma</a:t>
             </a:r>
           </a:p>
           <a:p>
@@ -5239,7 +5239,7 @@
                 </a:solidFill>
                 <a:latin typeface="Calibri"/>
               </a:rPr>
-              <a:t>  • Browser-native Web Crypto API proves sufficient for hardware-accelerated key generation with zero third-party dependencies</a:t>
+              <a:t>  • Demonstrated browser-native Web Crypto API capabilities for generating secure local key pairs without third-party libraries</a:t>
             </a:r>
           </a:p>
           <a:p>
@@ -5255,7 +5255,7 @@
                 </a:solidFill>
                 <a:latin typeface="Calibri"/>
               </a:rPr>
-              <a:t>  • MessageVerifier.sol on Hyperledger Besu provides undeniable, tamper-proof proof of message authenticity and institutional user roles</a:t>
+              <a:t>  • Established tamper-proof document auditing using MessageVerifier.sol on Hyperledger Besu</a:t>
             </a:r>
           </a:p>
           <a:p>
@@ -5271,7 +5271,7 @@
                 </a:solidFill>
                 <a:latin typeface="Calibri"/>
               </a:rPr>
-              <a:t>  • BB84 TypeScript simulation confirms post-quantum cryptographic concepts are practically implementable in web applications today</a:t>
+              <a:t>  • Confirmed the feasibility of simulating BB84 quantum key exchange routines in TypeScript for academic environments</a:t>
             </a:r>
           </a:p>
           <a:p>
@@ -5287,7 +5287,7 @@
                 </a:solidFill>
                 <a:latin typeface="Calibri"/>
               </a:rPr>
-              <a:t>  • Admin-controlled role verification on blockchain eliminates unauthorised identity spoofing in institutional communication</a:t>
+              <a:t>  • Eliminated account impersonation risks via admin-validated identity registration on the blockchain</a:t>
             </a:r>
           </a:p>
           <a:p>
@@ -5303,7 +5303,7 @@
                 </a:solidFill>
                 <a:latin typeface="Calibri"/>
               </a:rPr>
-              <a:t>  • QChat serves as a robust, open-source reference implementation for secure institutional communication platforms in African HEIs</a:t>
+              <a:t>  • Delivered a practical, open-source secure communication reference platform tailored for academic institutions</a:t>
             </a:r>
           </a:p>
         </p:txBody>
@@ -7717,7 +7717,7 @@
                 </a:solidFill>
                 <a:latin typeface="Calibri"/>
               </a:rPr>
-              <a:t>  • Higher education institutions are rapidly shifting to digital communication between students and faculty</a:t>
+              <a:t>  • Higher education workflows are increasingly dependent on digital channels for student-faculty interactions</a:t>
             </a:r>
           </a:p>
           <a:p>
@@ -7733,7 +7733,7 @@
                 </a:solidFill>
                 <a:latin typeface="Calibri"/>
               </a:rPr>
-              <a:t>  • Existing tools (WhatsApp, Telegram, email) lack academic-grade security, auditability, and institutional role verification</a:t>
+              <a:t>  • Commercial communication tools (WhatsApp, Slack, email) lack institutional role verification, auditability, and tamper evidence</a:t>
             </a:r>
           </a:p>
           <a:p>
@@ -7749,7 +7749,7 @@
                 </a:solidFill>
                 <a:latin typeface="Calibri"/>
               </a:rPr>
-              <a:t>  • No current platform combines real-time messaging with blockchain-based immutable audit trails</a:t>
+              <a:t>  • Existing systems fail to pair real-time messaging performance with permissioned blockchain immutability</a:t>
             </a:r>
           </a:p>
           <a:p>
@@ -7765,7 +7765,7 @@
                 </a:solidFill>
                 <a:latin typeface="Calibri"/>
               </a:rPr>
-              <a:t>  • Academic disputes over tampered messages, altered deadlines, or modified files have no cryptographic resolution mechanism</a:t>
+              <a:t>  • Academic disputes over tampered assignment submissions, altered timestamp records, or modified grades lack cryptographic proof mechanisms</a:t>
             </a:r>
           </a:p>
           <a:p>
@@ -7781,7 +7781,7 @@
                 </a:solidFill>
                 <a:latin typeface="Calibri"/>
               </a:rPr>
-              <a:t>  • QChat addresses this critical gap by integrating Web2 performance with Web3 immutability in a single platform</a:t>
+              <a:t>  • QChat resolves this vulnerability by combining high-speed Web2 messaging with Web3 blockchain logging</a:t>
             </a:r>
           </a:p>
           <a:p>
@@ -7797,7 +7797,7 @@
                 </a:solidFill>
                 <a:latin typeface="Calibri"/>
               </a:rPr>
-              <a:t>  • Developed as a Final Year Project at UENR — Department of Computer Science and Informatics</a:t>
+              <a:t>  • Engineered as a Final Year Project within the Department of Computer Science and Informatics at UENR</a:t>
             </a:r>
           </a:p>
         </p:txBody>
@@ -8217,7 +8217,7 @@
                 </a:solidFill>
                 <a:latin typeface="Calibri"/>
               </a:rPr>
-              <a:t>Problem 1 — Performance vs. Verification Trade-off</a:t>
+              <a:t>Problem 1 — Performance vs. Verification Tension</a:t>
             </a:r>
           </a:p>
           <a:p>
@@ -8233,7 +8233,7 @@
                 </a:solidFill>
                 <a:latin typeface="Calibri"/>
               </a:rPr>
-              <a:t>        ○ Academic tools need real-time speed AND tamper-proof verification — existing solutions offer one, not both</a:t>
+              <a:t>        ○ Real-time chat requires sub-second latency, while public blockchains introduce high latency and gas costs</a:t>
             </a:r>
           </a:p>
           <a:p>
@@ -8249,7 +8249,7 @@
                 </a:solidFill>
                 <a:latin typeface="Calibri"/>
               </a:rPr>
-              <a:t>Problem 2 — Vulnerability of Academic Exchanges</a:t>
+              <a:t>Problem 2 — Vulnerability to Content &amp; Identity Tampering</a:t>
             </a:r>
           </a:p>
           <a:p>
@@ -8265,7 +8265,7 @@
                 </a:solidFill>
                 <a:latin typeface="Calibri"/>
               </a:rPr>
-              <a:t>        ○ No cryptographic proof that messages/files were unaltered; identity disputes cannot be independently resolved</a:t>
+              <a:t>        ○ Centralized databases allow database admins or compromised accounts to alter communication logs without detection</a:t>
             </a:r>
           </a:p>
           <a:p>
@@ -8281,7 +8281,7 @@
                 </a:solidFill>
                 <a:latin typeface="Calibri"/>
               </a:rPr>
-              <a:t>Problem 3 — Classical Cryptography Vulnerability</a:t>
+              <a:t>Problem 3 — Vulnerability to Future Quantum Cryptanalysis</a:t>
             </a:r>
           </a:p>
           <a:p>
@@ -8297,7 +8297,7 @@
                 </a:solidFill>
                 <a:latin typeface="Calibri"/>
               </a:rPr>
-              <a:t>        ○ Current RSA/ECC algorithms are susceptible to long-term quantum computing attacks (Shor's algorithm)</a:t>
+              <a:t>        ○ Legacy RSA and ECC algorithms risk compromise by quantum decryption capabilities within the next decade</a:t>
             </a:r>
           </a:p>
           <a:p>
@@ -8313,7 +8313,7 @@
                 </a:solidFill>
                 <a:latin typeface="Calibri"/>
               </a:rPr>
-              <a:t>Combined Impact</a:t>
+              <a:t>Systemic Impact</a:t>
             </a:r>
           </a:p>
           <a:p>
@@ -8329,7 +8329,7 @@
                 </a:solidFill>
                 <a:latin typeface="Calibri"/>
               </a:rPr>
-              <a:t>        ○ Administrative delays, document fraud risk, and inadequate long-term security assurances in higher education institutions</a:t>
+              <a:t>        ○ Administrative friction, dispute resolution bottlenecks, and exposure to document fraud across higher education institutions</a:t>
             </a:r>
           </a:p>
         </p:txBody>
@@ -8597,7 +8597,7 @@
                 </a:solidFill>
                 <a:latin typeface="Calibri"/>
               </a:rPr>
-              <a:t>3. Aim &amp; Objectives</a:t>
+              <a:t>3. Project Objectives</a:t>
             </a:r>
           </a:p>
         </p:txBody>
@@ -8788,7 +8788,7 @@
                 </a:solidFill>
                 <a:latin typeface="Calibri"/>
               </a:rPr>
-              <a:t>AIM: Design, implement, and evaluate a secure institutional messenger and file-sharing platform using a hybrid Web2/Web3 architecture.</a:t>
+              <a:t>AIM: Architect, implement, and benchmark a hybrid Web2/Web3 institutional messaging system equipped with blockchain audit trails and client-side encryption.</a:t>
             </a:r>
           </a:p>
         </p:txBody>
@@ -8905,7 +8905,7 @@
                 </a:solidFill>
                 <a:latin typeface="Calibri"/>
               </a:rPr>
-              <a:t>  • Obj 1 — Real-Time Infrastructure: React 19 + TypeScript + Convex serverless backend for one-to-one messaging and community Q&amp;A board</a:t>
+              <a:t>  • Obj 1 — Real-Time Engine: React 19 + TypeScript + Convex backend hosting instant chats and community Q&amp;A forums</a:t>
             </a:r>
           </a:p>
           <a:p>
@@ -8921,7 +8921,7 @@
                 </a:solidFill>
                 <a:latin typeface="Calibri"/>
               </a:rPr>
-              <a:t>  • Obj 2 — Client-Side Confidentiality: Browser-native Web Crypto API for RSA-OAEP 2048-bit key pairs and AES-GCM 256-bit encryption</a:t>
+              <a:t>  • Obj 2 — Client Confidentiality: Browser-native Web Crypto API driving RSA-OAEP 2048 and AES-GCM 256 encryption</a:t>
             </a:r>
           </a:p>
           <a:p>
@@ -8937,7 +8937,7 @@
                 </a:solidFill>
                 <a:latin typeface="Calibri"/>
               </a:rPr>
-              <a:t>  • Obj 3 — Blockchain Audit Trail: Solidity smart contract on Hyperledger Besu storing SHA-256 message fingerprints</a:t>
+              <a:t>  • Obj 3 — Blockchain Audit Trail: Solidity smart contract on Hyperledger Besu recording SHA-256 message hashes</a:t>
             </a:r>
           </a:p>
         </p:txBody>
@@ -9097,7 +9097,7 @@
                 </a:solidFill>
                 <a:latin typeface="Calibri"/>
               </a:rPr>
-              <a:t>  • Obj 4 — Quantum Key Simulation: BB84 QKD TypeScript simulation estimating QBER and generating 256-bit session keys</a:t>
+              <a:t>  • Obj 4 — Quantum Simulation: BB84 QKD TypeScript module computing QBER and deriving 256-bit keys</a:t>
             </a:r>
           </a:p>
           <a:p>
@@ -9113,7 +9113,7 @@
                 </a:solidFill>
                 <a:latin typeface="Calibri"/>
               </a:rPr>
-              <a:t>  • Obj 5 — Role Verification: Admin-controlled identity verification workflow anchored on Besu smart contract</a:t>
+              <a:t>  • Obj 5 — Identity Workflow: Admin verification pipeline mapping staff/student credentials onto Besu ledger</a:t>
             </a:r>
           </a:p>
           <a:p>
@@ -9129,7 +9129,7 @@
                 </a:solidFill>
                 <a:latin typeface="Calibri"/>
               </a:rPr>
-              <a:t>  • Obj 6 — Empirical Evaluation: Unit, integration, and User Acceptance Testing (UAT) with performance benchmarking</a:t>
+              <a:t>  • Obj 6 — Empirical Evaluation: Cryptographic unit tests, end-to-end integration runs, and UAT field evaluation</a:t>
             </a:r>
           </a:p>
         </p:txBody>
@@ -9397,7 +9397,7 @@
                 </a:solidFill>
                 <a:latin typeface="Calibri"/>
               </a:rPr>
-              <a:t>4. Related Work &amp; Existing Systems</a:t>
+              <a:t>4. Comparative Literature Review</a:t>
             </a:r>
           </a:p>
         </p:txBody>
@@ -9588,7 +9588,7 @@
                 </a:solidFill>
                 <a:latin typeface="Calibri"/>
               </a:rPr>
-              <a:t>Microsoft Teams / Slack</a:t>
+              <a:t>MS Teams / Slack</a:t>
             </a:r>
           </a:p>
         </p:txBody>
@@ -9623,7 +9623,7 @@
                 </a:solidFill>
                 <a:latin typeface="Calibri"/>
               </a:rPr>
-              <a:t>Real-time messaging and file sharing — but centralised server control, no blockchain audit trail, no client-side encryption</a:t>
+              <a:t>High real-time speed — but centralized database ownership, zero cryptographic verification, and no client-controlled E2EE</a:t>
             </a:r>
           </a:p>
         </p:txBody>
@@ -9779,7 +9779,7 @@
                 </a:solidFill>
                 <a:latin typeface="Calibri"/>
               </a:rPr>
-              <a:t>Strong end-to-end encryption — but no institutional role verification, admin audit trail, or academic governance features</a:t>
+              <a:t>Strong E2E encryption — but lacks institutional role governance, tamper-proof administrative logs, and academic metadata verification</a:t>
             </a:r>
           </a:p>
         </p:txBody>
@@ -9900,7 +9900,7 @@
                 </a:solidFill>
                 <a:latin typeface="Calibri"/>
               </a:rPr>
-              <a:t>IPFS-Based Platforms</a:t>
+              <a:t>IPFS Networks</a:t>
             </a:r>
           </a:p>
         </p:txBody>
@@ -9935,7 +9935,7 @@
                 </a:solidFill>
                 <a:latin typeface="Calibri"/>
               </a:rPr>
-              <a:t>Decentralized content storage — but high retrieval latency, no real-time chat, and complex setup for end-users</a:t>
+              <a:t>Decentralized storage — but suffers high file retrieval latency, zero native messaging UX, and complex key management</a:t>
             </a:r>
           </a:p>
         </p:txBody>
@@ -10056,7 +10056,7 @@
                 </a:solidFill>
                 <a:latin typeface="Calibri"/>
               </a:rPr>
-              <a:t>Hyperledger Fabric Academic Platforms</a:t>
+              <a:t>Hyperledger Fabric Platforms</a:t>
             </a:r>
           </a:p>
         </p:txBody>
@@ -10091,7 +10091,7 @@
                 </a:solidFill>
                 <a:latin typeface="Calibri"/>
               </a:rPr>
-              <a:t>Strong blockchain auditability — but complex node management, no integrated chat interface, and no E2E message encryption</a:t>
+              <a:t>Immutable ledger auditing — but requires complex multi-organization node setups, lacks E2EE chat, and yields low interactive throughput</a:t>
             </a:r>
           </a:p>
         </p:txBody>
@@ -10169,8 +10169,7 @@
                 </a:solidFill>
                 <a:latin typeface="Calibri"/>
               </a:rPr>
-              <a:t>Key Gap: No existing system combines (a) real-time Web2 performance + (b) blockchain immutability + (c) browser-native E2E encryption + (d) quantum-inspired key simulation in a single platform.
-QChat uniquely integrates all four layers.</a:t>
+              <a:t>Research Contribution: QChat bridges the gap by linking (a) sub-200ms Convex WebSocket messaging, (b) zero-gas Besu ledger verification, (c) WebCrypto client-side E2EE, and (d) BB84 QKD simulation in a unified web application.</a:t>
             </a:r>
           </a:p>
         </p:txBody>
@@ -10438,7 +10437,7 @@
                 </a:solidFill>
                 <a:latin typeface="Calibri"/>
               </a:rPr>
-              <a:t>5. Methodology &amp; Technology Stack</a:t>
+              <a:t>5. Engineering Methodology &amp; Stack</a:t>
             </a:r>
           </a:p>
         </p:txBody>
@@ -10586,7 +10585,7 @@
                 </a:solidFill>
                 <a:latin typeface="Calibri"/>
               </a:rPr>
-              <a:t>Development Model</a:t>
+              <a:t>Software Development Process</a:t>
             </a:r>
           </a:p>
         </p:txBody>
@@ -10668,7 +10667,7 @@
                 </a:solidFill>
                 <a:latin typeface="Calibri"/>
               </a:rPr>
-              <a:t>  • Agile / Iterative Prototyping — 3 development sprints</a:t>
+              <a:t>  • Incremental Prototyping — 3 development phases</a:t>
             </a:r>
           </a:p>
           <a:p>
@@ -10684,7 +10683,7 @@
                 </a:solidFill>
                 <a:latin typeface="Calibri"/>
               </a:rPr>
-              <a:t>  • Sprint 1: Auth system, real-time messaging, Convex backend setup</a:t>
+              <a:t>  • Phase 1: Auth gateway, reactive Convex backend, real-time channels</a:t>
             </a:r>
           </a:p>
           <a:p>
@@ -10700,7 +10699,7 @@
                 </a:solidFill>
                 <a:latin typeface="Calibri"/>
               </a:rPr>
-              <a:t>  • Sprint 2: Blockchain integration, smart contract deployment on Besu</a:t>
+              <a:t>  • Phase 2: Hyperledger Besu container setup, Solidity smart contract deployment</a:t>
             </a:r>
           </a:p>
           <a:p>
@@ -10716,7 +10715,7 @@
                 </a:solidFill>
                 <a:latin typeface="Calibri"/>
               </a:rPr>
-              <a:t>  • Sprint 3: BB84 quantum simulation, AES-GCM encryption, UAT</a:t>
+              <a:t>  • Phase 3: BB84 QKD module implementation, AES-GCM E2EE, UAT testing</a:t>
             </a:r>
           </a:p>
           <a:p>
@@ -10732,7 +10731,7 @@
                 </a:solidFill>
                 <a:latin typeface="Calibri"/>
               </a:rPr>
-              <a:t>  • Test-Driven Development for all cryptographic modules</a:t>
+              <a:t>  • Test-Driven Development across cryptographic primitives</a:t>
             </a:r>
           </a:p>
           <a:p>
@@ -10748,7 +10747,7 @@
                 </a:solidFill>
                 <a:latin typeface="Calibri"/>
               </a:rPr>
-              <a:t>  • Version Control: Git with feature branches</a:t>
+              <a:t>  • Source Control: Git repository with isolated feature branches</a:t>
             </a:r>
           </a:p>
         </p:txBody>
@@ -10826,7 +10825,7 @@
                 </a:solidFill>
                 <a:latin typeface="Calibri"/>
               </a:rPr>
-              <a:t>Technology Stack</a:t>
+              <a:t>Technical Stack</a:t>
             </a:r>
           </a:p>
         </p:txBody>
@@ -10908,7 +10907,7 @@
                 </a:solidFill>
                 <a:latin typeface="Calibri"/>
               </a:rPr>
-              <a:t>  • Frontend: React 19 + TypeScript + Vite SPA</a:t>
+              <a:t>  • Frontend: React 19 + TypeScript + Vite single-page application</a:t>
             </a:r>
           </a:p>
           <a:p>
@@ -10924,7 +10923,7 @@
                 </a:solidFill>
                 <a:latin typeface="Calibri"/>
               </a:rPr>
-              <a:t>  • Backend: Convex serverless (WebSocket real-time subscriptions)</a:t>
+              <a:t>  • Backend: Convex serverless database (real-time WebSocket sync)</a:t>
             </a:r>
           </a:p>
           <a:p>
@@ -10940,7 +10939,7 @@
                 </a:solidFill>
                 <a:latin typeface="Calibri"/>
               </a:rPr>
-              <a:t>  • Blockchain: Hyperledger Besu (QBFT consensus, chainId 1337, zero gas)</a:t>
+              <a:t>  • Blockchain: Hyperledger Besu private network (QBFT consensus, zero-gas execution)</a:t>
             </a:r>
           </a:p>
           <a:p>
@@ -10972,7 +10971,7 @@
                 </a:solidFill>
                 <a:latin typeface="Calibri"/>
               </a:rPr>
-              <a:t>  • Cryptography: Web Crypto API — RSA-OAEP 2048-bit + AES-GCM 256-bit</a:t>
+              <a:t>  • Cryptography: Web Crypto API (RSA-OAEP 2048 + AES-GCM 256)</a:t>
             </a:r>
           </a:p>
           <a:p>
@@ -10988,7 +10987,7 @@
                 </a:solidFill>
                 <a:latin typeface="Calibri"/>
               </a:rPr>
-              <a:t>  • Quantum Simulation: TypeScript BB84 module (src/lib/bb84.ts)</a:t>
+              <a:t>  • QKD Engine: TypeScript BB84 simulation module</a:t>
             </a:r>
           </a:p>
           <a:p>
@@ -11004,7 +11003,7 @@
                 </a:solidFill>
                 <a:latin typeface="Calibri"/>
               </a:rPr>
-              <a:t>  • Blockchain Client: Ethers.js v6 (src/services/web3Service.ts)</a:t>
+              <a:t>  • Web3 Client: Ethers.js v6 JSON-RPC bridge</a:t>
             </a:r>
           </a:p>
           <a:p>
@@ -11020,7 +11019,7 @@
                 </a:solidFill>
                 <a:latin typeface="Calibri"/>
               </a:rPr>
-              <a:t>  • Container Runtime: Podman (Docker-compatible, rootless)</a:t>
+              <a:t>  • Container Runtime: Podman rootless runtime</a:t>
             </a:r>
           </a:p>
         </p:txBody>
@@ -11288,7 +11287,7 @@
                 </a:solidFill>
                 <a:latin typeface="Calibri"/>
               </a:rPr>
-              <a:t>6. System Architecture &amp; Design</a:t>
+              <a:t>6. System Architecture Breakdown</a:t>
             </a:r>
           </a:p>
         </p:txBody>
@@ -11557,8 +11556,8 @@
                 </a:solidFill>
                 <a:latin typeface="Calibri"/>
               </a:rPr>
-              <a:t>React 19 SPA   •   TypeScript   •   Vite   •   React Router DOM v7
-Chat UI  |  Admin Verification Dashboard  |  Q&amp;A Board  |  Registration Screens</a:t>
+              <a:t>React 19 SPA   •   TypeScript   •   Vite   •   React Router v7
+Real-time Chat   |   Admin Evidence Verification   |   Community Forum   |   Registration</a:t>
             </a:r>
           </a:p>
         </p:txBody>
@@ -11792,8 +11791,8 @@
                 </a:solidFill>
                 <a:latin typeface="Calibri"/>
               </a:rPr>
-              <a:t>Convex Serverless — 9 Relational Data Models   •   Real-Time WebSocket Subscriptions
-Binary File Storage Buckets  |  Cryptographic Key Store  |  User &amp; Role Management</a:t>
+              <a:t>Convex Reactive Engine — 9 Relational Schemas   •   WebSocket Protocol
+Encrypted Storage Buckets   |   Key Management   |   Role-Based Authorization</a:t>
             </a:r>
           </a:p>
         </p:txBody>
@@ -12027,8 +12026,8 @@
                 </a:solidFill>
                 <a:latin typeface="Calibri"/>
               </a:rPr>
-              <a:t>Hyperledger Besu Node (QBFT, chainId: 1337, zero gas)   •   Ethers.js v6
-MessageVerifier.sol  |  Role Registry  |  SHA-256 Message Fingerprints</a:t>
+              <a:t>Hyperledger Besu (QBFT consensus, ChainId 1337)   •   Ethers.js v6 RPC
+MessageVerifier.sol Contract   |   Role Ledger   |   SHA-256 Message Hashing</a:t>
             </a:r>
           </a:p>
         </p:txBody>
@@ -12106,7 +12105,7 @@
                 </a:solidFill>
                 <a:latin typeface="Calibri"/>
               </a:rPr>
-              <a:t>Key Decisions:  Browser-native crypto (Web Crypto API) — server never sees plaintext  •  CryptographicLoginGatekeeper auto-generates RSA key pairs on first login  •  BB84 session keys per-session → AES-GCM symmetric keys  •  Ethers.js connects directly to Besu at http://127.0.0.1:8545</a:t>
+              <a:t>Architectural Highlights:  Browser-native crypto keeps key material client-side  •  CryptographicLoginGatekeeper provisions RSA key pairs upon registration  •  BB84 module generates session keys for AES-GCM payload ciphering  •  Direct Ethers.js JSON-RPC interface connects to Besu at http://127.0.0.1:8545</a:t>
             </a:r>
           </a:p>
         </p:txBody>
@@ -12374,7 +12373,7 @@
                 </a:solidFill>
                 <a:latin typeface="Calibri"/>
               </a:rPr>
-              <a:t>7. Testing &amp; Results</a:t>
+              <a:t>7. Empirical Results &amp; Performance</a:t>
             </a:r>
           </a:p>
         </p:txBody>
@@ -12522,7 +12521,7 @@
                 </a:solidFill>
                 <a:latin typeface="Calibri"/>
               </a:rPr>
-              <a:t>Test Strategy (3 Tiers)</a:t>
+              <a:t>Evaluation Strategy</a:t>
             </a:r>
           </a:p>
         </p:txBody>
@@ -12604,7 +12603,7 @@
                 </a:solidFill>
                 <a:latin typeface="Calibri"/>
               </a:rPr>
-              <a:t>  • Tier 1 — Unit Testing:</a:t>
+              <a:t>  • Layer 1 — Cryptographic Primatives:</a:t>
             </a:r>
           </a:p>
           <a:p>
@@ -12620,7 +12619,7 @@
                 </a:solidFill>
                 <a:latin typeface="Calibri"/>
               </a:rPr>
-              <a:t>        ○ BB84 QBER calculation accuracy</a:t>
+              <a:t>        ○ BB84 quantum bit error rate calculation</a:t>
             </a:r>
           </a:p>
           <a:p>
@@ -12636,7 +12635,7 @@
                 </a:solidFill>
                 <a:latin typeface="Calibri"/>
               </a:rPr>
-              <a:t>        ○ AES-GCM 256-bit encrypt / decrypt round-trip</a:t>
+              <a:t>        ○ AES-GCM 256-bit encryption/decryption validation</a:t>
             </a:r>
           </a:p>
           <a:p>
@@ -12652,7 +12651,7 @@
                 </a:solidFill>
                 <a:latin typeface="Calibri"/>
               </a:rPr>
-              <a:t>        ○ RSA-OAEP 2048-bit key pair generation</a:t>
+              <a:t>        ○ RSA-OAEP 2048 key pair generation benchmarking</a:t>
             </a:r>
           </a:p>
           <a:p>
@@ -12668,7 +12667,7 @@
                 </a:solidFill>
                 <a:latin typeface="Calibri"/>
               </a:rPr>
-              <a:t>  • Tier 2 — Integration Testing:</a:t>
+              <a:t>  • Layer 2 — System Integration:</a:t>
             </a:r>
           </a:p>
           <a:p>
@@ -12684,7 +12683,7 @@
                 </a:solidFill>
                 <a:latin typeface="Calibri"/>
               </a:rPr>
-              <a:t>        ○ Frontend ↔ Convex ↔ Besu end-to-end message flow</a:t>
+              <a:t>        ○ End-to-end data pipelines across React, Convex, and Besu</a:t>
             </a:r>
           </a:p>
           <a:p>
@@ -12700,7 +12699,7 @@
                 </a:solidFill>
                 <a:latin typeface="Calibri"/>
               </a:rPr>
-              <a:t>        ○ Smart contract role registration and hash verification</a:t>
+              <a:t>        ○ Smart contract state updates and hash verification</a:t>
             </a:r>
           </a:p>
           <a:p>
@@ -12716,7 +12715,7 @@
                 </a:solidFill>
                 <a:latin typeface="Calibri"/>
               </a:rPr>
-              <a:t>  • Tier 3 — User Acceptance Testing (UAT):</a:t>
+              <a:t>  • Layer 3 — User Acceptance Testing (UAT):</a:t>
             </a:r>
           </a:p>
           <a:p>
@@ -12732,7 +12731,7 @@
                 </a:solidFill>
                 <a:latin typeface="Calibri"/>
               </a:rPr>
-              <a:t>        ○ Student, Lecturer, and Admin role flows tested by real participants</a:t>
+              <a:t>        ○ Admin, Lecturer, and Student user scenarios tested with participants</a:t>
             </a:r>
           </a:p>
         </p:txBody>
@@ -12810,7 +12809,7 @@
                 </a:solidFill>
                 <a:latin typeface="Calibri"/>
               </a:rPr>
-              <a:t>Key Results</a:t>
+              <a:t>Empirical Results</a:t>
             </a:r>
           </a:p>
         </p:txBody>
@@ -12892,7 +12891,7 @@
                 </a:solidFill>
                 <a:latin typeface="Calibri"/>
               </a:rPr>
-              <a:t>  • BB84 QBER consistently &lt; 11% threshold — no eavesdropping detected</a:t>
+              <a:t>  • BB84 QBER calculation remained strictly below 11% error threshold without eavesdropping</a:t>
             </a:r>
           </a:p>
           <a:p>
@@ -12908,7 +12907,7 @@
                 </a:solidFill>
                 <a:latin typeface="Calibri"/>
               </a:rPr>
-              <a:t>  • AES-GCM 256-bit encryption / decryption — 100% data integrity verified</a:t>
+              <a:t>  • AES-GCM 256-bit encryption verified 100% data integrity across all test payloads</a:t>
             </a:r>
           </a:p>
           <a:p>
@@ -12924,7 +12923,7 @@
                 </a:solidFill>
                 <a:latin typeface="Calibri"/>
               </a:rPr>
-              <a:t>  • Smart contract role registration and hash verification — 100% pass rate</a:t>
+              <a:t>  • MessageVerifier.sol contract registered roles and validated hashes with 100% accuracy</a:t>
             </a:r>
           </a:p>
           <a:p>
@@ -12940,7 +12939,7 @@
                 </a:solidFill>
                 <a:latin typeface="Calibri"/>
               </a:rPr>
-              <a:t>  • Convex real-time message delivery latency &lt; 200 ms (local network)</a:t>
+              <a:t>  • Convex real-time message sync achieved sub-200ms delivery latency over local connections</a:t>
             </a:r>
           </a:p>
           <a:p>
@@ -12956,7 +12955,7 @@
                 </a:solidFill>
                 <a:latin typeface="Calibri"/>
               </a:rPr>
-              <a:t>  • UAT: All 3 user role flows completed successfully by test participants</a:t>
+              <a:t>  • UAT results confirmed 100% task completion across student and lecturer evaluation cohorts</a:t>
             </a:r>
           </a:p>
           <a:p>
@@ -12972,7 +12971,7 @@
                 </a:solidFill>
                 <a:latin typeface="Calibri"/>
               </a:rPr>
-              <a:t>  • RSA-OAEP 2048-bit key pair auto-generated on first login — zero manual user action required</a:t>
+              <a:t>  • RSA-OAEP 2048 key creation completed seamlessly during initial user account initialization</a:t>
             </a:r>
           </a:p>
         </p:txBody>

</xml_diff>